<commit_message>
Korrekturen in Blinkbeispiel 3
</commit_message>
<xml_diff>
--- a/2_Sensorik/2.1_Arduino/2.1_Arduino.pptx
+++ b/2_Sensorik/2.1_Arduino/2.1_Arduino.pptx
@@ -296,7 +296,7 @@
           <a:p>
             <a:fld id="{028B6593-098D-4382-9647-35487FA190B4}" type="datetimeFigureOut">
               <a:rPr lang="de-DE" smtClean="0"/>
-              <a:t>10.03.2026</a:t>
+              <a:t>13.04.2026</a:t>
             </a:fld>
             <a:endParaRPr lang="de-DE"/>
           </a:p>
@@ -16951,7 +16951,7 @@
         </p:nvSpPr>
         <p:spPr>
           <a:xfrm>
-            <a:off x="4383177" y="6064178"/>
+            <a:off x="4041468" y="6064178"/>
             <a:ext cx="5425440" cy="215444"/>
           </a:xfrm>
           <a:prstGeom prst="rect">
@@ -17005,9 +17005,33 @@
           </a:prstGeom>
         </p:spPr>
       </p:pic>
+      <p:sp>
+        <p:nvSpPr>
+          <p:cNvPr id="7" name="Foliennummernplatzhalter 6"/>
+          <p:cNvSpPr>
+            <a:spLocks noGrp="1"/>
+          </p:cNvSpPr>
+          <p:nvPr>
+            <p:ph type="sldNum" sz="quarter" idx="11"/>
+          </p:nvPr>
+        </p:nvSpPr>
+        <p:spPr/>
+        <p:txBody>
+          <a:bodyPr/>
+          <a:lstStyle/>
+          <a:p>
+            <a:fld id="{93869C99-C634-47CD-B208-CB16ACE119EE}" type="slidenum">
+              <a:rPr lang="de-DE" smtClean="0"/>
+              <a:pPr/>
+              <a:t>21</a:t>
+            </a:fld>
+            <a:endParaRPr lang="de-DE"/>
+          </a:p>
+        </p:txBody>
+      </p:sp>
       <p:pic>
         <p:nvPicPr>
-          <p:cNvPr id="6" name="Grafik 5"/>
+          <p:cNvPr id="2" name="Grafik 1"/>
           <p:cNvPicPr>
             <a:picLocks noChangeAspect="1"/>
           </p:cNvPicPr>
@@ -17021,38 +17045,14 @@
         </p:blipFill>
         <p:spPr>
           <a:xfrm>
-            <a:off x="4382448" y="1686946"/>
-            <a:ext cx="7092000" cy="4377232"/>
+            <a:off x="4041468" y="1529299"/>
+            <a:ext cx="7360036" cy="4534879"/>
           </a:xfrm>
           <a:prstGeom prst="rect">
             <a:avLst/>
           </a:prstGeom>
         </p:spPr>
       </p:pic>
-      <p:sp>
-        <p:nvSpPr>
-          <p:cNvPr id="7" name="Foliennummernplatzhalter 6"/>
-          <p:cNvSpPr>
-            <a:spLocks noGrp="1"/>
-          </p:cNvSpPr>
-          <p:nvPr>
-            <p:ph type="sldNum" sz="quarter" idx="11"/>
-          </p:nvPr>
-        </p:nvSpPr>
-        <p:spPr/>
-        <p:txBody>
-          <a:bodyPr/>
-          <a:lstStyle/>
-          <a:p>
-            <a:fld id="{93869C99-C634-47CD-B208-CB16ACE119EE}" type="slidenum">
-              <a:rPr lang="de-DE" smtClean="0"/>
-              <a:pPr/>
-              <a:t>21</a:t>
-            </a:fld>
-            <a:endParaRPr lang="de-DE"/>
-          </a:p>
-        </p:txBody>
-      </p:sp>
     </p:spTree>
     <p:extLst>
       <p:ext uri="{BB962C8B-B14F-4D97-AF65-F5344CB8AC3E}">
@@ -17201,7 +17201,7 @@
         </p:nvSpPr>
         <p:spPr>
           <a:xfrm>
-            <a:off x="4383177" y="6064178"/>
+            <a:off x="4023031" y="6064178"/>
             <a:ext cx="5425440" cy="215444"/>
           </a:xfrm>
           <a:prstGeom prst="rect">
@@ -17291,7 +17291,7 @@
       </p:pic>
       <p:pic>
         <p:nvPicPr>
-          <p:cNvPr id="4" name="Grafik 3"/>
+          <p:cNvPr id="3" name="Grafik 2"/>
           <p:cNvPicPr>
             <a:picLocks noChangeAspect="1"/>
           </p:cNvPicPr>
@@ -17305,8 +17305,8 @@
         </p:blipFill>
         <p:spPr>
           <a:xfrm>
-            <a:off x="4383177" y="1705080"/>
-            <a:ext cx="7091271" cy="4359098"/>
+            <a:off x="4023031" y="1597984"/>
+            <a:ext cx="7292670" cy="4466194"/>
           </a:xfrm>
           <a:prstGeom prst="rect">
             <a:avLst/>
@@ -24240,18 +24240,18 @@
 </file>
 
 <file path=customXml/item1.xml><?xml version="1.0" encoding="utf-8"?>
-<p:properties xmlns:p="http://schemas.microsoft.com/office/2006/metadata/properties" xmlns:xsi="http://www.w3.org/2001/XMLSchema-instance" xmlns:pc="http://schemas.microsoft.com/office/infopath/2007/PartnerControls">
-  <documentManagement/>
-</p:properties>
-</file>
-
-<file path=customXml/item2.xml><?xml version="1.0" encoding="utf-8"?>
 <?mso-contentType ?>
 <FormTemplates xmlns="http://schemas.microsoft.com/sharepoint/v3/contenttype/forms">
   <Display>DocumentLibraryForm</Display>
   <Edit>DocumentLibraryForm</Edit>
   <New>DocumentLibraryForm</New>
 </FormTemplates>
+</file>
+
+<file path=customXml/item2.xml><?xml version="1.0" encoding="utf-8"?>
+<p:properties xmlns:p="http://schemas.microsoft.com/office/2006/metadata/properties" xmlns:xsi="http://www.w3.org/2001/XMLSchema-instance" xmlns:pc="http://schemas.microsoft.com/office/infopath/2007/PartnerControls">
+  <documentManagement/>
+</p:properties>
 </file>
 
 <file path=customXml/item3.xml><?xml version="1.0" encoding="utf-8"?>
@@ -24403,6 +24403,14 @@
 </file>
 
 <file path=customXml/itemProps1.xml><?xml version="1.0" encoding="utf-8"?>
+<ds:datastoreItem xmlns:ds="http://schemas.openxmlformats.org/officeDocument/2006/customXml" ds:itemID="{AE15DEB7-8D29-4EC4-857C-8778EFE70922}">
+  <ds:schemaRefs>
+    <ds:schemaRef ds:uri="http://schemas.microsoft.com/sharepoint/v3/contenttype/forms"/>
+  </ds:schemaRefs>
+</ds:datastoreItem>
+</file>
+
+<file path=customXml/itemProps2.xml><?xml version="1.0" encoding="utf-8"?>
 <ds:datastoreItem xmlns:ds="http://schemas.openxmlformats.org/officeDocument/2006/customXml" ds:itemID="{4D9AF071-B304-4F0F-8459-AC4D742E5C60}">
   <ds:schemaRefs>
     <ds:schemaRef ds:uri="http://purl.org/dc/dcmitype/"/>
@@ -24414,14 +24422,6 @@
     <ds:schemaRef ds:uri="http://schemas.openxmlformats.org/package/2006/metadata/core-properties"/>
     <ds:schemaRef ds:uri="http://schemas.microsoft.com/office/2006/metadata/properties"/>
     <ds:schemaRef ds:uri="http://www.w3.org/XML/1998/namespace"/>
-  </ds:schemaRefs>
-</ds:datastoreItem>
-</file>
-
-<file path=customXml/itemProps2.xml><?xml version="1.0" encoding="utf-8"?>
-<ds:datastoreItem xmlns:ds="http://schemas.openxmlformats.org/officeDocument/2006/customXml" ds:itemID="{AE15DEB7-8D29-4EC4-857C-8778EFE70922}">
-  <ds:schemaRefs>
-    <ds:schemaRef ds:uri="http://schemas.microsoft.com/sharepoint/v3/contenttype/forms"/>
   </ds:schemaRefs>
 </ds:datastoreItem>
 </file>

</xml_diff>